<commit_message>
Update refactoring for ATPESC 2026
</commit_message>
<xml_diff>
--- a/refactoring.pptx
+++ b/refactoring.pptx
@@ -12,7 +12,7 @@
   </p:handoutMasterIdLst>
   <p:sldIdLst>
     <p:sldId id="256" r:id="rId5"/>
-    <p:sldId id="668" r:id="rId6"/>
+    <p:sldId id="320" r:id="rId6"/>
     <p:sldId id="610" r:id="rId7"/>
     <p:sldId id="625" r:id="rId8"/>
     <p:sldId id="495" r:id="rId9"/>
@@ -285,7 +285,7 @@
           <a:p>
             <a:fld id="{0B842F42-2CE9-4E35-95C1-410DC08A50B1}" type="datetimeFigureOut">
               <a:rPr lang="en-US" smtClean="0"/>
-              <a:t>1/16/26</a:t>
+              <a:t>8/2/2026</a:t>
             </a:fld>
             <a:endParaRPr lang="en-US"/>
           </a:p>
@@ -450,7 +450,7 @@
           <a:p>
             <a:fld id="{6F282904-F315-4730-8D91-37D99E141A6F}" type="datetimeFigureOut">
               <a:rPr lang="en-US" smtClean="0"/>
-              <a:t>1/16/26</a:t>
+              <a:t>8/2/2026</a:t>
             </a:fld>
             <a:endParaRPr lang="en-US"/>
           </a:p>
@@ -1800,42 +1800,6 @@
       </p:sp>
       <p:pic>
         <p:nvPicPr>
-          <p:cNvPr id="3" name="Picture 2">
-            <a:extLst>
-              <a:ext uri="{FF2B5EF4-FFF2-40B4-BE49-F238E27FC236}">
-                <a16:creationId xmlns:a16="http://schemas.microsoft.com/office/drawing/2014/main" id="{E5A81C43-A5B9-D933-9CA0-B9EBBA5B6295}"/>
-              </a:ext>
-            </a:extLst>
-          </p:cNvPr>
-          <p:cNvPicPr>
-            <a:picLocks noChangeAspect="1"/>
-          </p:cNvPicPr>
-          <p:nvPr userDrawn="1"/>
-        </p:nvPicPr>
-        <p:blipFill>
-          <a:blip r:embed="rId3" cstate="print">
-            <a:extLst>
-              <a:ext uri="{28A0092B-C50C-407E-A947-70E740481C1C}">
-                <a14:useLocalDpi xmlns:a14="http://schemas.microsoft.com/office/drawing/2010/main" val="0"/>
-              </a:ext>
-            </a:extLst>
-          </a:blip>
-          <a:stretch>
-            <a:fillRect/>
-          </a:stretch>
-        </p:blipFill>
-        <p:spPr>
-          <a:xfrm>
-            <a:off x="418659" y="158509"/>
-            <a:ext cx="2109916" cy="905256"/>
-          </a:xfrm>
-          <a:prstGeom prst="rect">
-            <a:avLst/>
-          </a:prstGeom>
-        </p:spPr>
-      </p:pic>
-      <p:pic>
-        <p:nvPicPr>
           <p:cNvPr id="31" name="Picture 30">
             <a:extLst>
               <a:ext uri="{FF2B5EF4-FFF2-40B4-BE49-F238E27FC236}">
@@ -1849,11 +1813,11 @@
           <p:nvPr userDrawn="1"/>
         </p:nvPicPr>
         <p:blipFill>
-          <a:blip r:embed="rId4" cstate="print">
+          <a:blip r:embed="rId3" cstate="print">
             <a:extLst>
               <a:ext uri="{BEBA8EAE-BF5A-486C-A8C5-ECC9F3942E4B}">
                 <a14:imgProps xmlns:a14="http://schemas.microsoft.com/office/drawing/2010/main">
-                  <a14:imgLayer r:embed="rId5">
+                  <a14:imgLayer r:embed="rId4">
                     <a14:imgEffect>
                       <a14:brightnessContrast bright="100000"/>
                     </a14:imgEffect>
@@ -1879,12 +1843,48 @@
           </a:prstGeom>
         </p:spPr>
       </p:pic>
+      <p:pic>
+        <p:nvPicPr>
+          <p:cNvPr id="5" name="Picture 4">
+            <a:extLst>
+              <a:ext uri="{FF2B5EF4-FFF2-40B4-BE49-F238E27FC236}">
+                <a16:creationId xmlns:a16="http://schemas.microsoft.com/office/drawing/2014/main" id="{A500A7AD-A439-9DBF-A79E-EE8A4250143E}"/>
+              </a:ext>
+            </a:extLst>
+          </p:cNvPr>
+          <p:cNvPicPr>
+            <a:picLocks noChangeAspect="1"/>
+          </p:cNvPicPr>
+          <p:nvPr userDrawn="1"/>
+        </p:nvPicPr>
+        <p:blipFill>
+          <a:blip r:embed="rId5" cstate="print">
+            <a:extLst>
+              <a:ext uri="{28A0092B-C50C-407E-A947-70E740481C1C}">
+                <a14:useLocalDpi xmlns:a14="http://schemas.microsoft.com/office/drawing/2010/main" val="0"/>
+              </a:ext>
+            </a:extLst>
+          </a:blip>
+          <a:stretch>
+            <a:fillRect/>
+          </a:stretch>
+        </p:blipFill>
+        <p:spPr>
+          <a:xfrm>
+            <a:off x="296061" y="158509"/>
+            <a:ext cx="2109916" cy="905256"/>
+          </a:xfrm>
+          <a:prstGeom prst="rect">
+            <a:avLst/>
+          </a:prstGeom>
+        </p:spPr>
+      </p:pic>
       <p:sp>
         <p:nvSpPr>
-          <p:cNvPr id="8" name="TextBox 7">
+          <p:cNvPr id="7" name="TextBox 6">
             <a:extLst>
               <a:ext uri="{FF2B5EF4-FFF2-40B4-BE49-F238E27FC236}">
-                <a16:creationId xmlns:a16="http://schemas.microsoft.com/office/drawing/2014/main" id="{C5F5D814-D023-0C77-62AF-7101AD3419A6}"/>
+                <a16:creationId xmlns:a16="http://schemas.microsoft.com/office/drawing/2014/main" id="{FB44DC9F-7539-E840-88A8-C7B43824C81F}"/>
               </a:ext>
             </a:extLst>
           </p:cNvPr>
@@ -1893,7 +1893,7 @@
         </p:nvSpPr>
         <p:spPr>
           <a:xfrm>
-            <a:off x="901538" y="1454246"/>
+            <a:off x="778940" y="1454246"/>
             <a:ext cx="1144159" cy="350865"/>
           </a:xfrm>
           <a:prstGeom prst="rect">
@@ -1921,10 +1921,10 @@
       </p:sp>
       <p:sp>
         <p:nvSpPr>
-          <p:cNvPr id="12" name="TextBox 11">
+          <p:cNvPr id="10" name="TextBox 9">
             <a:extLst>
               <a:ext uri="{FF2B5EF4-FFF2-40B4-BE49-F238E27FC236}">
-                <a16:creationId xmlns:a16="http://schemas.microsoft.com/office/drawing/2014/main" id="{B5D8D9CE-072B-C278-A349-03A28D3CA873}"/>
+                <a16:creationId xmlns:a16="http://schemas.microsoft.com/office/drawing/2014/main" id="{361B6646-501A-EC80-DC44-34C59530B335}"/>
               </a:ext>
             </a:extLst>
           </p:cNvPr>
@@ -1933,8 +1933,8 @@
         </p:nvSpPr>
         <p:spPr>
           <a:xfrm>
-            <a:off x="948025" y="2646131"/>
-            <a:ext cx="1051185" cy="350865"/>
+            <a:off x="863899" y="2646131"/>
+            <a:ext cx="974241" cy="350865"/>
           </a:xfrm>
           <a:prstGeom prst="rect">
             <a:avLst/>
@@ -1954,17 +1954,17 @@
             </a:pPr>
             <a:r>
               <a:rPr lang="en-US" sz="1200" i="1" dirty="0"/>
-              <a:t>Members of</a:t>
+              <a:t>Member of</a:t>
             </a:r>
           </a:p>
         </p:txBody>
       </p:sp>
       <p:sp>
         <p:nvSpPr>
-          <p:cNvPr id="15" name="TextBox 14">
+          <p:cNvPr id="18" name="TextBox 17">
             <a:extLst>
               <a:ext uri="{FF2B5EF4-FFF2-40B4-BE49-F238E27FC236}">
-                <a16:creationId xmlns:a16="http://schemas.microsoft.com/office/drawing/2014/main" id="{85E13C4D-0FCB-AD8A-F919-219CD45F5E4E}"/>
+                <a16:creationId xmlns:a16="http://schemas.microsoft.com/office/drawing/2014/main" id="{B6F633AC-EEA0-A973-C5EF-855894DE0105}"/>
               </a:ext>
             </a:extLst>
           </p:cNvPr>
@@ -1973,7 +1973,7 @@
         </p:nvSpPr>
         <p:spPr>
           <a:xfrm>
-            <a:off x="572120" y="4624321"/>
+            <a:off x="449522" y="4624321"/>
             <a:ext cx="1802994" cy="350865"/>
           </a:xfrm>
           <a:prstGeom prst="rect">
@@ -2001,10 +2001,10 @@
       </p:sp>
       <p:grpSp>
         <p:nvGrpSpPr>
-          <p:cNvPr id="16" name="Group 15">
+          <p:cNvPr id="19" name="Group 18">
             <a:extLst>
               <a:ext uri="{FF2B5EF4-FFF2-40B4-BE49-F238E27FC236}">
-                <a16:creationId xmlns:a16="http://schemas.microsoft.com/office/drawing/2014/main" id="{7289C683-CE7C-A99C-90B4-4FDEE2708869}"/>
+                <a16:creationId xmlns:a16="http://schemas.microsoft.com/office/drawing/2014/main" id="{E7943264-26AF-9347-A41C-66D3E775E85C}"/>
               </a:ext>
             </a:extLst>
           </p:cNvPr>
@@ -2013,7 +2013,7 @@
         </p:nvGrpSpPr>
         <p:grpSpPr>
           <a:xfrm>
-            <a:off x="355043" y="5027111"/>
+            <a:off x="232445" y="5027111"/>
             <a:ext cx="2237149" cy="457200"/>
             <a:chOff x="343050" y="5128711"/>
             <a:chExt cx="2237149" cy="457200"/>
@@ -2021,10 +2021,10 @@
         </p:grpSpPr>
         <p:pic>
           <p:nvPicPr>
-            <p:cNvPr id="17" name="Picture 16">
+            <p:cNvPr id="24" name="Picture 23">
               <a:extLst>
                 <a:ext uri="{FF2B5EF4-FFF2-40B4-BE49-F238E27FC236}">
-                  <a16:creationId xmlns:a16="http://schemas.microsoft.com/office/drawing/2014/main" id="{C37C7687-369C-B25A-E795-965CAC0F0430}"/>
+                  <a16:creationId xmlns:a16="http://schemas.microsoft.com/office/drawing/2014/main" id="{AAB63604-C388-4D35-3F4F-C3F1553C8175}"/>
                 </a:ext>
               </a:extLst>
             </p:cNvPr>
@@ -2057,10 +2057,10 @@
         </p:pic>
         <p:pic>
           <p:nvPicPr>
-            <p:cNvPr id="30" name="Picture 29" descr="A picture containing shape&#10;&#10;Description automatically generated">
+            <p:cNvPr id="25" name="Picture 24" descr="A picture containing shape&#10;&#10;Description automatically generated">
               <a:extLst>
                 <a:ext uri="{FF2B5EF4-FFF2-40B4-BE49-F238E27FC236}">
-                  <a16:creationId xmlns:a16="http://schemas.microsoft.com/office/drawing/2014/main" id="{4B33E9E5-DA31-2040-6905-662BE26E895B}"/>
+                  <a16:creationId xmlns:a16="http://schemas.microsoft.com/office/drawing/2014/main" id="{52AC66E1-8AF4-2CB5-46C1-43BA3D869271}"/>
                 </a:ext>
               </a:extLst>
             </p:cNvPr>
@@ -2092,213 +2092,59 @@
           </p:spPr>
         </p:pic>
       </p:grpSp>
-      <p:grpSp>
-        <p:nvGrpSpPr>
-          <p:cNvPr id="32" name="Group 31">
+      <p:pic>
+        <p:nvPicPr>
+          <p:cNvPr id="26" name="Picture 2" descr="A picture containing graphics, logo, font, symbol&#10;&#10;Description automatically generated">
             <a:extLst>
               <a:ext uri="{FF2B5EF4-FFF2-40B4-BE49-F238E27FC236}">
-                <a16:creationId xmlns:a16="http://schemas.microsoft.com/office/drawing/2014/main" id="{207C4F59-640F-DF87-D6D1-98C999629E33}"/>
+                <a16:creationId xmlns:a16="http://schemas.microsoft.com/office/drawing/2014/main" id="{E4079972-8219-DCD7-95BA-DF35B43C8A0F}"/>
               </a:ext>
             </a:extLst>
           </p:cNvPr>
-          <p:cNvGrpSpPr/>
+          <p:cNvPicPr>
+            <a:picLocks noChangeAspect="1" noChangeArrowheads="1"/>
+          </p:cNvPicPr>
           <p:nvPr userDrawn="1"/>
-        </p:nvGrpSpPr>
-        <p:grpSpPr>
-          <a:xfrm>
-            <a:off x="-69503" y="1892144"/>
-            <a:ext cx="2985270" cy="790169"/>
-            <a:chOff x="-69503" y="2214872"/>
-            <a:chExt cx="2985270" cy="790169"/>
-          </a:xfrm>
-        </p:grpSpPr>
-        <p:pic>
-          <p:nvPicPr>
-            <p:cNvPr id="33" name="Picture 4">
-              <a:extLst>
-                <a:ext uri="{FF2B5EF4-FFF2-40B4-BE49-F238E27FC236}">
-                  <a16:creationId xmlns:a16="http://schemas.microsoft.com/office/drawing/2014/main" id="{FC66403F-CB60-0332-773E-4539ADA0C9F5}"/>
-                </a:ext>
-              </a:extLst>
-            </p:cNvPr>
-            <p:cNvPicPr>
-              <a:picLocks noChangeAspect="1" noChangeArrowheads="1"/>
-            </p:cNvPicPr>
-            <p:nvPr userDrawn="1"/>
-          </p:nvPicPr>
-          <p:blipFill>
-            <a:blip r:embed="rId8" cstate="print">
-              <a:extLst>
-                <a:ext uri="{28A0092B-C50C-407E-A947-70E740481C1C}">
-                  <a14:useLocalDpi xmlns:a14="http://schemas.microsoft.com/office/drawing/2010/main" val="0"/>
-                </a:ext>
-              </a:extLst>
-            </a:blip>
-            <a:srcRect/>
-            <a:stretch>
-              <a:fillRect/>
-            </a:stretch>
-          </p:blipFill>
-          <p:spPr bwMode="auto">
-            <a:xfrm>
-              <a:off x="1484438" y="2317122"/>
-              <a:ext cx="1371600" cy="318873"/>
-            </a:xfrm>
-            <a:prstGeom prst="rect">
-              <a:avLst/>
-            </a:prstGeom>
-            <a:noFill/>
+        </p:nvPicPr>
+        <p:blipFill>
+          <a:blip r:embed="rId8" cstate="print">
             <a:extLst>
-              <a:ext uri="{909E8E84-426E-40DD-AFC4-6F175D3DCCD1}">
-                <a14:hiddenFill xmlns:a14="http://schemas.microsoft.com/office/drawing/2010/main">
-                  <a:solidFill>
-                    <a:srgbClr val="FFFFFF"/>
-                  </a:solidFill>
-                </a14:hiddenFill>
+              <a:ext uri="{28A0092B-C50C-407E-A947-70E740481C1C}">
+                <a14:useLocalDpi xmlns:a14="http://schemas.microsoft.com/office/drawing/2010/main" val="0"/>
               </a:ext>
             </a:extLst>
-          </p:spPr>
-        </p:pic>
-        <p:pic>
-          <p:nvPicPr>
-            <p:cNvPr id="34" name="Picture 2" descr="A picture containing graphics, logo, font, symbol&#10;&#10;Description automatically generated">
-              <a:extLst>
-                <a:ext uri="{FF2B5EF4-FFF2-40B4-BE49-F238E27FC236}">
-                  <a16:creationId xmlns:a16="http://schemas.microsoft.com/office/drawing/2014/main" id="{3E2AFFBD-3575-2847-9AAF-6E6A96862D76}"/>
-                </a:ext>
-              </a:extLst>
-            </p:cNvPr>
-            <p:cNvPicPr>
-              <a:picLocks noChangeAspect="1" noChangeArrowheads="1"/>
-            </p:cNvPicPr>
-            <p:nvPr userDrawn="1"/>
-          </p:nvPicPr>
-          <p:blipFill>
-            <a:blip r:embed="rId9" cstate="print">
-              <a:extLst>
-                <a:ext uri="{28A0092B-C50C-407E-A947-70E740481C1C}">
-                  <a14:useLocalDpi xmlns:a14="http://schemas.microsoft.com/office/drawing/2010/main" val="0"/>
-                </a:ext>
-              </a:extLst>
-            </a:blip>
-            <a:srcRect/>
-            <a:stretch>
-              <a:fillRect/>
-            </a:stretch>
-          </p:blipFill>
-          <p:spPr bwMode="auto">
-            <a:xfrm>
-              <a:off x="321595" y="2214872"/>
-              <a:ext cx="841248" cy="523372"/>
-            </a:xfrm>
-            <a:prstGeom prst="rect">
-              <a:avLst/>
-            </a:prstGeom>
-            <a:noFill/>
-            <a:extLst>
-              <a:ext uri="{909E8E84-426E-40DD-AFC4-6F175D3DCCD1}">
-                <a14:hiddenFill xmlns:a14="http://schemas.microsoft.com/office/drawing/2010/main">
-                  <a:solidFill>
-                    <a:srgbClr val="FFFFFF"/>
-                  </a:solidFill>
-                </a14:hiddenFill>
-              </a:ext>
-            </a:extLst>
-          </p:spPr>
-        </p:pic>
-        <p:sp>
-          <p:nvSpPr>
-            <p:cNvPr id="35" name="TextBox 34">
-              <a:extLst>
-                <a:ext uri="{FF2B5EF4-FFF2-40B4-BE49-F238E27FC236}">
-                  <a16:creationId xmlns:a16="http://schemas.microsoft.com/office/drawing/2014/main" id="{5E39CEC8-98B1-7568-653D-E9AE26511499}"/>
-                </a:ext>
-              </a:extLst>
-            </p:cNvPr>
-            <p:cNvSpPr txBox="1"/>
-            <p:nvPr userDrawn="1"/>
-          </p:nvSpPr>
-          <p:spPr>
-            <a:xfrm>
-              <a:off x="-69503" y="2668026"/>
-              <a:ext cx="1631472" cy="337015"/>
-            </a:xfrm>
-            <a:prstGeom prst="rect">
-              <a:avLst/>
-            </a:prstGeom>
-            <a:noFill/>
-          </p:spPr>
-          <p:txBody>
-            <a:bodyPr wrap="none" lIns="118872" tIns="91440" rIns="118872" bIns="91440" rtlCol="0" anchor="ctr" anchorCtr="0">
-              <a:spAutoFit/>
-            </a:bodyPr>
-            <a:lstStyle/>
-            <a:p>
-              <a:pPr algn="l">
-                <a:lnSpc>
-                  <a:spcPct val="90000"/>
-                </a:lnSpc>
-              </a:pPr>
-              <a:r>
-                <a:rPr lang="en-US" sz="1050" i="1" dirty="0">
-                  <a:hlinkClick r:id="rId10"/>
-                </a:rPr>
-                <a:t>https://pesoproject.org</a:t>
-              </a:r>
-              <a:endParaRPr lang="en-US" sz="1050" i="1" dirty="0"/>
-            </a:p>
-          </p:txBody>
-        </p:sp>
-        <p:sp>
-          <p:nvSpPr>
-            <p:cNvPr id="36" name="TextBox 35">
-              <a:extLst>
-                <a:ext uri="{FF2B5EF4-FFF2-40B4-BE49-F238E27FC236}">
-                  <a16:creationId xmlns:a16="http://schemas.microsoft.com/office/drawing/2014/main" id="{212AE08A-8A6C-79CC-3F21-161F7C72E3FF}"/>
-                </a:ext>
-              </a:extLst>
-            </p:cNvPr>
-            <p:cNvSpPr txBox="1"/>
-            <p:nvPr userDrawn="1"/>
-          </p:nvSpPr>
-          <p:spPr>
-            <a:xfrm>
-              <a:off x="1423755" y="2668026"/>
-              <a:ext cx="1492012" cy="337015"/>
-            </a:xfrm>
-            <a:prstGeom prst="rect">
-              <a:avLst/>
-            </a:prstGeom>
-            <a:noFill/>
-          </p:spPr>
-          <p:txBody>
-            <a:bodyPr wrap="none" lIns="118872" tIns="91440" rIns="118872" bIns="91440" rtlCol="0" anchor="ctr" anchorCtr="0">
-              <a:spAutoFit/>
-            </a:bodyPr>
-            <a:lstStyle/>
-            <a:p>
-              <a:pPr algn="l">
-                <a:lnSpc>
-                  <a:spcPct val="90000"/>
-                </a:lnSpc>
-              </a:pPr>
-              <a:r>
-                <a:rPr lang="en-US" sz="1050" i="1" dirty="0">
-                  <a:hlinkClick r:id="rId11"/>
-                </a:rPr>
-                <a:t>https://rapids.lbl.gov</a:t>
-              </a:r>
-              <a:endParaRPr lang="en-US" sz="1050" i="1" dirty="0"/>
-            </a:p>
-          </p:txBody>
-        </p:sp>
-      </p:grpSp>
+          </a:blip>
+          <a:srcRect/>
+          <a:stretch>
+            <a:fillRect/>
+          </a:stretch>
+        </p:blipFill>
+        <p:spPr bwMode="auto">
+          <a:xfrm>
+            <a:off x="930395" y="1892144"/>
+            <a:ext cx="841248" cy="523372"/>
+          </a:xfrm>
+          <a:prstGeom prst="rect">
+            <a:avLst/>
+          </a:prstGeom>
+          <a:noFill/>
+          <a:extLst>
+            <a:ext uri="{909E8E84-426E-40DD-AFC4-6F175D3DCCD1}">
+              <a14:hiddenFill xmlns:a14="http://schemas.microsoft.com/office/drawing/2010/main">
+                <a:solidFill>
+                  <a:srgbClr val="FFFFFF"/>
+                </a:solidFill>
+              </a14:hiddenFill>
+            </a:ext>
+          </a:extLst>
+        </p:spPr>
+      </p:pic>
       <p:sp>
         <p:nvSpPr>
-          <p:cNvPr id="37" name="TextBox 36">
+          <p:cNvPr id="27" name="TextBox 26">
             <a:extLst>
               <a:ext uri="{FF2B5EF4-FFF2-40B4-BE49-F238E27FC236}">
-                <a16:creationId xmlns:a16="http://schemas.microsoft.com/office/drawing/2014/main" id="{158D4700-C4CE-C2F9-D0A7-06799F81F594}"/>
+                <a16:creationId xmlns:a16="http://schemas.microsoft.com/office/drawing/2014/main" id="{47E37F57-5BB2-E45F-F76E-68C5CC4F05E7}"/>
               </a:ext>
             </a:extLst>
           </p:cNvPr>
@@ -2307,7 +2153,50 @@
         </p:nvSpPr>
         <p:spPr>
           <a:xfrm>
-            <a:off x="166031" y="4011401"/>
+            <a:off x="535283" y="2345298"/>
+            <a:ext cx="1631472" cy="337015"/>
+          </a:xfrm>
+          <a:prstGeom prst="rect">
+            <a:avLst/>
+          </a:prstGeom>
+          <a:noFill/>
+        </p:spPr>
+        <p:txBody>
+          <a:bodyPr wrap="none" lIns="118872" tIns="91440" rIns="118872" bIns="91440" rtlCol="0" anchor="ctr" anchorCtr="0">
+            <a:spAutoFit/>
+          </a:bodyPr>
+          <a:lstStyle/>
+          <a:p>
+            <a:pPr algn="l">
+              <a:lnSpc>
+                <a:spcPct val="90000"/>
+              </a:lnSpc>
+            </a:pPr>
+            <a:r>
+              <a:rPr lang="en-US" sz="1050" i="1" dirty="0">
+                <a:hlinkClick r:id="rId9"/>
+              </a:rPr>
+              <a:t>https://pesoproject.org</a:t>
+            </a:r>
+            <a:endParaRPr lang="en-US" sz="1050" i="1" dirty="0"/>
+          </a:p>
+        </p:txBody>
+      </p:sp>
+      <p:sp>
+        <p:nvSpPr>
+          <p:cNvPr id="28" name="TextBox 27">
+            <a:extLst>
+              <a:ext uri="{FF2B5EF4-FFF2-40B4-BE49-F238E27FC236}">
+                <a16:creationId xmlns:a16="http://schemas.microsoft.com/office/drawing/2014/main" id="{61FDFBA3-80E8-8E37-DEC9-AAA38E9064B5}"/>
+              </a:ext>
+            </a:extLst>
+          </p:cNvPr>
+          <p:cNvSpPr txBox="1"/>
+          <p:nvPr userDrawn="1"/>
+        </p:nvSpPr>
+        <p:spPr>
+          <a:xfrm>
+            <a:off x="48264" y="4011401"/>
             <a:ext cx="2605511" cy="655564"/>
           </a:xfrm>
           <a:prstGeom prst="rect">
@@ -2335,7 +2224,7 @@
             </a:br>
             <a:r>
               <a:rPr lang="en-US" sz="1000" i="1" dirty="0">
-                <a:hlinkClick r:id="rId12"/>
+                <a:hlinkClick r:id="rId10"/>
               </a:rPr>
               <a:t>https://cass.community</a:t>
             </a:r>
@@ -2345,10 +2234,10 @@
       </p:sp>
       <p:pic>
         <p:nvPicPr>
-          <p:cNvPr id="38" name="Picture 37" descr="A picture containing arrow&#10;&#10;AI-generated content may be incorrect.">
+          <p:cNvPr id="29" name="Picture 28" descr="A picture containing arrow&#10;&#10;AI-generated content may be incorrect.">
             <a:extLst>
               <a:ext uri="{FF2B5EF4-FFF2-40B4-BE49-F238E27FC236}">
-                <a16:creationId xmlns:a16="http://schemas.microsoft.com/office/drawing/2014/main" id="{C35E018A-A812-4862-A6E5-340C47A4832A}"/>
+                <a16:creationId xmlns:a16="http://schemas.microsoft.com/office/drawing/2014/main" id="{385D6AD8-4764-8B7E-8DD1-1154933CB01C}"/>
               </a:ext>
             </a:extLst>
           </p:cNvPr>
@@ -2358,7 +2247,7 @@
           <p:nvPr userDrawn="1"/>
         </p:nvPicPr>
         <p:blipFill>
-          <a:blip r:embed="rId13" cstate="print">
+          <a:blip r:embed="rId11" cstate="print">
             <a:extLst>
               <a:ext uri="{28A0092B-C50C-407E-A947-70E740481C1C}">
                 <a14:useLocalDpi xmlns:a14="http://schemas.microsoft.com/office/drawing/2010/main" val="0"/>
@@ -2371,7 +2260,7 @@
         </p:blipFill>
         <p:spPr>
           <a:xfrm>
-            <a:off x="849769" y="2974535"/>
+            <a:off x="732002" y="2974535"/>
             <a:ext cx="1238034" cy="1128739"/>
           </a:xfrm>
           <a:prstGeom prst="rect">
@@ -2836,10 +2725,10 @@
       </p:sp>
       <p:pic>
         <p:nvPicPr>
-          <p:cNvPr id="5" name="Picture 4">
+          <p:cNvPr id="6" name="Picture 5">
             <a:extLst>
               <a:ext uri="{FF2B5EF4-FFF2-40B4-BE49-F238E27FC236}">
-                <a16:creationId xmlns:a16="http://schemas.microsoft.com/office/drawing/2014/main" id="{39A0B7EC-D4C0-0A37-EF93-54309C1E7E8C}"/>
+                <a16:creationId xmlns:a16="http://schemas.microsoft.com/office/drawing/2014/main" id="{60EF9AE0-4B6F-9F47-747A-59BD194C894C}"/>
               </a:ext>
             </a:extLst>
           </p:cNvPr>
@@ -2862,7 +2751,7 @@
         </p:blipFill>
         <p:spPr>
           <a:xfrm>
-            <a:off x="418659" y="158509"/>
+            <a:off x="296061" y="158509"/>
             <a:ext cx="2109916" cy="905256"/>
           </a:xfrm>
           <a:prstGeom prst="rect">
@@ -2872,10 +2761,10 @@
       </p:pic>
       <p:sp>
         <p:nvSpPr>
-          <p:cNvPr id="12" name="TextBox 11">
+          <p:cNvPr id="7" name="TextBox 6">
             <a:extLst>
               <a:ext uri="{FF2B5EF4-FFF2-40B4-BE49-F238E27FC236}">
-                <a16:creationId xmlns:a16="http://schemas.microsoft.com/office/drawing/2014/main" id="{2FF8162C-FE3B-2F12-EFB5-7DF3B974D63A}"/>
+                <a16:creationId xmlns:a16="http://schemas.microsoft.com/office/drawing/2014/main" id="{17B1AF5D-C9EE-7615-4B1F-B74BF801EA40}"/>
               </a:ext>
             </a:extLst>
           </p:cNvPr>
@@ -2884,7 +2773,7 @@
         </p:nvSpPr>
         <p:spPr>
           <a:xfrm>
-            <a:off x="901538" y="1454246"/>
+            <a:off x="778940" y="1454246"/>
             <a:ext cx="1144159" cy="350865"/>
           </a:xfrm>
           <a:prstGeom prst="rect">
@@ -2912,10 +2801,10 @@
       </p:sp>
       <p:sp>
         <p:nvSpPr>
-          <p:cNvPr id="19" name="TextBox 18">
+          <p:cNvPr id="8" name="TextBox 7">
             <a:extLst>
               <a:ext uri="{FF2B5EF4-FFF2-40B4-BE49-F238E27FC236}">
-                <a16:creationId xmlns:a16="http://schemas.microsoft.com/office/drawing/2014/main" id="{D2820F98-3B22-7A7C-C5D3-A451E4190BE0}"/>
+                <a16:creationId xmlns:a16="http://schemas.microsoft.com/office/drawing/2014/main" id="{78C6E4F7-A494-D62A-6C6C-D62AED18227F}"/>
               </a:ext>
             </a:extLst>
           </p:cNvPr>
@@ -2924,8 +2813,8 @@
         </p:nvSpPr>
         <p:spPr>
           <a:xfrm>
-            <a:off x="948025" y="2646131"/>
-            <a:ext cx="1051185" cy="350865"/>
+            <a:off x="863899" y="2646131"/>
+            <a:ext cx="974241" cy="350865"/>
           </a:xfrm>
           <a:prstGeom prst="rect">
             <a:avLst/>
@@ -2945,17 +2834,17 @@
             </a:pPr>
             <a:r>
               <a:rPr lang="en-US" sz="1200" i="1" dirty="0"/>
-              <a:t>Members of</a:t>
+              <a:t>Member of</a:t>
             </a:r>
           </a:p>
         </p:txBody>
       </p:sp>
       <p:sp>
         <p:nvSpPr>
-          <p:cNvPr id="23" name="TextBox 22">
+          <p:cNvPr id="9" name="TextBox 8">
             <a:extLst>
               <a:ext uri="{FF2B5EF4-FFF2-40B4-BE49-F238E27FC236}">
-                <a16:creationId xmlns:a16="http://schemas.microsoft.com/office/drawing/2014/main" id="{C39CAFBB-B26F-D973-C4F5-75C0DBD17BC8}"/>
+                <a16:creationId xmlns:a16="http://schemas.microsoft.com/office/drawing/2014/main" id="{1A212EA0-CB7E-A8D5-3E18-377D20F982EF}"/>
               </a:ext>
             </a:extLst>
           </p:cNvPr>
@@ -2964,7 +2853,7 @@
         </p:nvSpPr>
         <p:spPr>
           <a:xfrm>
-            <a:off x="572120" y="4624321"/>
+            <a:off x="449522" y="4624321"/>
             <a:ext cx="1802994" cy="350865"/>
           </a:xfrm>
           <a:prstGeom prst="rect">
@@ -2992,10 +2881,10 @@
       </p:sp>
       <p:grpSp>
         <p:nvGrpSpPr>
-          <p:cNvPr id="24" name="Group 23">
+          <p:cNvPr id="10" name="Group 9">
             <a:extLst>
               <a:ext uri="{FF2B5EF4-FFF2-40B4-BE49-F238E27FC236}">
-                <a16:creationId xmlns:a16="http://schemas.microsoft.com/office/drawing/2014/main" id="{273B7CB2-1661-339F-C3CF-B7841A4249CF}"/>
+                <a16:creationId xmlns:a16="http://schemas.microsoft.com/office/drawing/2014/main" id="{E0B4F92E-904D-57B2-29B1-F0B7EC030DAE}"/>
               </a:ext>
             </a:extLst>
           </p:cNvPr>
@@ -3004,7 +2893,7 @@
         </p:nvGrpSpPr>
         <p:grpSpPr>
           <a:xfrm>
-            <a:off x="355043" y="5027111"/>
+            <a:off x="232445" y="5027111"/>
             <a:ext cx="2237149" cy="457200"/>
             <a:chOff x="343050" y="5128711"/>
             <a:chExt cx="2237149" cy="457200"/>
@@ -3012,10 +2901,10 @@
         </p:grpSpPr>
         <p:pic>
           <p:nvPicPr>
-            <p:cNvPr id="25" name="Picture 24">
+            <p:cNvPr id="11" name="Picture 10">
               <a:extLst>
                 <a:ext uri="{FF2B5EF4-FFF2-40B4-BE49-F238E27FC236}">
-                  <a16:creationId xmlns:a16="http://schemas.microsoft.com/office/drawing/2014/main" id="{20E1B50D-7456-26E6-E71B-C2EFC86CD852}"/>
+                  <a16:creationId xmlns:a16="http://schemas.microsoft.com/office/drawing/2014/main" id="{6AC71928-9267-7CFE-35A8-6CD1DB001564}"/>
                 </a:ext>
               </a:extLst>
             </p:cNvPr>
@@ -3048,10 +2937,10 @@
         </p:pic>
         <p:pic>
           <p:nvPicPr>
-            <p:cNvPr id="26" name="Picture 25" descr="A picture containing shape&#10;&#10;Description automatically generated">
+            <p:cNvPr id="15" name="Picture 14" descr="A picture containing shape&#10;&#10;Description automatically generated">
               <a:extLst>
                 <a:ext uri="{FF2B5EF4-FFF2-40B4-BE49-F238E27FC236}">
-                  <a16:creationId xmlns:a16="http://schemas.microsoft.com/office/drawing/2014/main" id="{CCF4F055-BFB5-5FA7-5DAE-B7C31519A851}"/>
+                  <a16:creationId xmlns:a16="http://schemas.microsoft.com/office/drawing/2014/main" id="{B30AA384-1BBB-0CEA-BFB0-F101BAD60C91}"/>
                 </a:ext>
               </a:extLst>
             </p:cNvPr>
@@ -3083,213 +2972,59 @@
           </p:spPr>
         </p:pic>
       </p:grpSp>
-      <p:grpSp>
-        <p:nvGrpSpPr>
-          <p:cNvPr id="27" name="Group 26">
+      <p:pic>
+        <p:nvPicPr>
+          <p:cNvPr id="17" name="Picture 2" descr="A picture containing graphics, logo, font, symbol&#10;&#10;Description automatically generated">
             <a:extLst>
               <a:ext uri="{FF2B5EF4-FFF2-40B4-BE49-F238E27FC236}">
-                <a16:creationId xmlns:a16="http://schemas.microsoft.com/office/drawing/2014/main" id="{D346F560-6C4A-637B-95AE-00BA10A56548}"/>
+                <a16:creationId xmlns:a16="http://schemas.microsoft.com/office/drawing/2014/main" id="{4FB792EA-D32A-08C6-3FBD-FC1AF81F262E}"/>
               </a:ext>
             </a:extLst>
           </p:cNvPr>
-          <p:cNvGrpSpPr/>
+          <p:cNvPicPr>
+            <a:picLocks noChangeAspect="1" noChangeArrowheads="1"/>
+          </p:cNvPicPr>
           <p:nvPr userDrawn="1"/>
-        </p:nvGrpSpPr>
-        <p:grpSpPr>
-          <a:xfrm>
-            <a:off x="-69503" y="1892144"/>
-            <a:ext cx="2985270" cy="790169"/>
-            <a:chOff x="-69503" y="2214872"/>
-            <a:chExt cx="2985270" cy="790169"/>
-          </a:xfrm>
-        </p:grpSpPr>
-        <p:pic>
-          <p:nvPicPr>
-            <p:cNvPr id="28" name="Picture 4">
-              <a:extLst>
-                <a:ext uri="{FF2B5EF4-FFF2-40B4-BE49-F238E27FC236}">
-                  <a16:creationId xmlns:a16="http://schemas.microsoft.com/office/drawing/2014/main" id="{32D9E63D-4D7F-616E-6CFA-84EF3251CEDC}"/>
-                </a:ext>
-              </a:extLst>
-            </p:cNvPr>
-            <p:cNvPicPr>
-              <a:picLocks noChangeAspect="1" noChangeArrowheads="1"/>
-            </p:cNvPicPr>
-            <p:nvPr userDrawn="1"/>
-          </p:nvPicPr>
-          <p:blipFill>
-            <a:blip r:embed="rId8" cstate="print">
-              <a:extLst>
-                <a:ext uri="{28A0092B-C50C-407E-A947-70E740481C1C}">
-                  <a14:useLocalDpi xmlns:a14="http://schemas.microsoft.com/office/drawing/2010/main" val="0"/>
-                </a:ext>
-              </a:extLst>
-            </a:blip>
-            <a:srcRect/>
-            <a:stretch>
-              <a:fillRect/>
-            </a:stretch>
-          </p:blipFill>
-          <p:spPr bwMode="auto">
-            <a:xfrm>
-              <a:off x="1484438" y="2317122"/>
-              <a:ext cx="1371600" cy="318873"/>
-            </a:xfrm>
-            <a:prstGeom prst="rect">
-              <a:avLst/>
-            </a:prstGeom>
-            <a:noFill/>
+        </p:nvPicPr>
+        <p:blipFill>
+          <a:blip r:embed="rId8" cstate="print">
             <a:extLst>
-              <a:ext uri="{909E8E84-426E-40DD-AFC4-6F175D3DCCD1}">
-                <a14:hiddenFill xmlns:a14="http://schemas.microsoft.com/office/drawing/2010/main">
-                  <a:solidFill>
-                    <a:srgbClr val="FFFFFF"/>
-                  </a:solidFill>
-                </a14:hiddenFill>
+              <a:ext uri="{28A0092B-C50C-407E-A947-70E740481C1C}">
+                <a14:useLocalDpi xmlns:a14="http://schemas.microsoft.com/office/drawing/2010/main" val="0"/>
               </a:ext>
             </a:extLst>
-          </p:spPr>
-        </p:pic>
-        <p:pic>
-          <p:nvPicPr>
-            <p:cNvPr id="29" name="Picture 2" descr="A picture containing graphics, logo, font, symbol&#10;&#10;Description automatically generated">
-              <a:extLst>
-                <a:ext uri="{FF2B5EF4-FFF2-40B4-BE49-F238E27FC236}">
-                  <a16:creationId xmlns:a16="http://schemas.microsoft.com/office/drawing/2014/main" id="{C3DD0F40-8227-1760-99FF-A46AF01BB816}"/>
-                </a:ext>
-              </a:extLst>
-            </p:cNvPr>
-            <p:cNvPicPr>
-              <a:picLocks noChangeAspect="1" noChangeArrowheads="1"/>
-            </p:cNvPicPr>
-            <p:nvPr userDrawn="1"/>
-          </p:nvPicPr>
-          <p:blipFill>
-            <a:blip r:embed="rId9" cstate="print">
-              <a:extLst>
-                <a:ext uri="{28A0092B-C50C-407E-A947-70E740481C1C}">
-                  <a14:useLocalDpi xmlns:a14="http://schemas.microsoft.com/office/drawing/2010/main" val="0"/>
-                </a:ext>
-              </a:extLst>
-            </a:blip>
-            <a:srcRect/>
-            <a:stretch>
-              <a:fillRect/>
-            </a:stretch>
-          </p:blipFill>
-          <p:spPr bwMode="auto">
-            <a:xfrm>
-              <a:off x="321595" y="2214872"/>
-              <a:ext cx="841248" cy="523372"/>
-            </a:xfrm>
-            <a:prstGeom prst="rect">
-              <a:avLst/>
-            </a:prstGeom>
-            <a:noFill/>
-            <a:extLst>
-              <a:ext uri="{909E8E84-426E-40DD-AFC4-6F175D3DCCD1}">
-                <a14:hiddenFill xmlns:a14="http://schemas.microsoft.com/office/drawing/2010/main">
-                  <a:solidFill>
-                    <a:srgbClr val="FFFFFF"/>
-                  </a:solidFill>
-                </a14:hiddenFill>
-              </a:ext>
-            </a:extLst>
-          </p:spPr>
-        </p:pic>
-        <p:sp>
-          <p:nvSpPr>
-            <p:cNvPr id="30" name="TextBox 29">
-              <a:extLst>
-                <a:ext uri="{FF2B5EF4-FFF2-40B4-BE49-F238E27FC236}">
-                  <a16:creationId xmlns:a16="http://schemas.microsoft.com/office/drawing/2014/main" id="{CC397930-9AA6-7A6A-76AA-0832111D6B80}"/>
-                </a:ext>
-              </a:extLst>
-            </p:cNvPr>
-            <p:cNvSpPr txBox="1"/>
-            <p:nvPr userDrawn="1"/>
-          </p:nvSpPr>
-          <p:spPr>
-            <a:xfrm>
-              <a:off x="-69503" y="2668026"/>
-              <a:ext cx="1631472" cy="337015"/>
-            </a:xfrm>
-            <a:prstGeom prst="rect">
-              <a:avLst/>
-            </a:prstGeom>
-            <a:noFill/>
-          </p:spPr>
-          <p:txBody>
-            <a:bodyPr wrap="none" lIns="118872" tIns="91440" rIns="118872" bIns="91440" rtlCol="0" anchor="ctr" anchorCtr="0">
-              <a:spAutoFit/>
-            </a:bodyPr>
-            <a:lstStyle/>
-            <a:p>
-              <a:pPr algn="l">
-                <a:lnSpc>
-                  <a:spcPct val="90000"/>
-                </a:lnSpc>
-              </a:pPr>
-              <a:r>
-                <a:rPr lang="en-US" sz="1050" i="1" dirty="0">
-                  <a:hlinkClick r:id="rId10"/>
-                </a:rPr>
-                <a:t>https://pesoproject.org</a:t>
-              </a:r>
-              <a:endParaRPr lang="en-US" sz="1050" i="1" dirty="0"/>
-            </a:p>
-          </p:txBody>
-        </p:sp>
-        <p:sp>
-          <p:nvSpPr>
-            <p:cNvPr id="31" name="TextBox 30">
-              <a:extLst>
-                <a:ext uri="{FF2B5EF4-FFF2-40B4-BE49-F238E27FC236}">
-                  <a16:creationId xmlns:a16="http://schemas.microsoft.com/office/drawing/2014/main" id="{3D9CC300-2021-70DB-ED4C-4241A2BFF3CD}"/>
-                </a:ext>
-              </a:extLst>
-            </p:cNvPr>
-            <p:cNvSpPr txBox="1"/>
-            <p:nvPr userDrawn="1"/>
-          </p:nvSpPr>
-          <p:spPr>
-            <a:xfrm>
-              <a:off x="1423755" y="2668026"/>
-              <a:ext cx="1492012" cy="337015"/>
-            </a:xfrm>
-            <a:prstGeom prst="rect">
-              <a:avLst/>
-            </a:prstGeom>
-            <a:noFill/>
-          </p:spPr>
-          <p:txBody>
-            <a:bodyPr wrap="none" lIns="118872" tIns="91440" rIns="118872" bIns="91440" rtlCol="0" anchor="ctr" anchorCtr="0">
-              <a:spAutoFit/>
-            </a:bodyPr>
-            <a:lstStyle/>
-            <a:p>
-              <a:pPr algn="l">
-                <a:lnSpc>
-                  <a:spcPct val="90000"/>
-                </a:lnSpc>
-              </a:pPr>
-              <a:r>
-                <a:rPr lang="en-US" sz="1050" i="1" dirty="0">
-                  <a:hlinkClick r:id="rId11"/>
-                </a:rPr>
-                <a:t>https://rapids.lbl.gov</a:t>
-              </a:r>
-              <a:endParaRPr lang="en-US" sz="1050" i="1" dirty="0"/>
-            </a:p>
-          </p:txBody>
-        </p:sp>
-      </p:grpSp>
+          </a:blip>
+          <a:srcRect/>
+          <a:stretch>
+            <a:fillRect/>
+          </a:stretch>
+        </p:blipFill>
+        <p:spPr bwMode="auto">
+          <a:xfrm>
+            <a:off x="930395" y="1892144"/>
+            <a:ext cx="841248" cy="523372"/>
+          </a:xfrm>
+          <a:prstGeom prst="rect">
+            <a:avLst/>
+          </a:prstGeom>
+          <a:noFill/>
+          <a:extLst>
+            <a:ext uri="{909E8E84-426E-40DD-AFC4-6F175D3DCCD1}">
+              <a14:hiddenFill xmlns:a14="http://schemas.microsoft.com/office/drawing/2010/main">
+                <a:solidFill>
+                  <a:srgbClr val="FFFFFF"/>
+                </a:solidFill>
+              </a14:hiddenFill>
+            </a:ext>
+          </a:extLst>
+        </p:spPr>
+      </p:pic>
       <p:sp>
         <p:nvSpPr>
-          <p:cNvPr id="32" name="TextBox 31">
+          <p:cNvPr id="18" name="TextBox 17">
             <a:extLst>
               <a:ext uri="{FF2B5EF4-FFF2-40B4-BE49-F238E27FC236}">
-                <a16:creationId xmlns:a16="http://schemas.microsoft.com/office/drawing/2014/main" id="{1913CA0B-B952-F608-0A2C-CCD7844E5E43}"/>
+                <a16:creationId xmlns:a16="http://schemas.microsoft.com/office/drawing/2014/main" id="{217C07DA-D587-667D-151C-984B914C86A6}"/>
               </a:ext>
             </a:extLst>
           </p:cNvPr>
@@ -3298,7 +3033,50 @@
         </p:nvSpPr>
         <p:spPr>
           <a:xfrm>
-            <a:off x="166031" y="4011401"/>
+            <a:off x="535283" y="2345298"/>
+            <a:ext cx="1631472" cy="337015"/>
+          </a:xfrm>
+          <a:prstGeom prst="rect">
+            <a:avLst/>
+          </a:prstGeom>
+          <a:noFill/>
+        </p:spPr>
+        <p:txBody>
+          <a:bodyPr wrap="none" lIns="118872" tIns="91440" rIns="118872" bIns="91440" rtlCol="0" anchor="ctr" anchorCtr="0">
+            <a:spAutoFit/>
+          </a:bodyPr>
+          <a:lstStyle/>
+          <a:p>
+            <a:pPr algn="l">
+              <a:lnSpc>
+                <a:spcPct val="90000"/>
+              </a:lnSpc>
+            </a:pPr>
+            <a:r>
+              <a:rPr lang="en-US" sz="1050" i="1" dirty="0">
+                <a:hlinkClick r:id="rId9"/>
+              </a:rPr>
+              <a:t>https://pesoproject.org</a:t>
+            </a:r>
+            <a:endParaRPr lang="en-US" sz="1050" i="1" dirty="0"/>
+          </a:p>
+        </p:txBody>
+      </p:sp>
+      <p:sp>
+        <p:nvSpPr>
+          <p:cNvPr id="20" name="TextBox 19">
+            <a:extLst>
+              <a:ext uri="{FF2B5EF4-FFF2-40B4-BE49-F238E27FC236}">
+                <a16:creationId xmlns:a16="http://schemas.microsoft.com/office/drawing/2014/main" id="{AA5D1E85-1850-E4B4-F511-C254447B5490}"/>
+              </a:ext>
+            </a:extLst>
+          </p:cNvPr>
+          <p:cNvSpPr txBox="1"/>
+          <p:nvPr userDrawn="1"/>
+        </p:nvSpPr>
+        <p:spPr>
+          <a:xfrm>
+            <a:off x="48264" y="4011401"/>
             <a:ext cx="2605511" cy="655564"/>
           </a:xfrm>
           <a:prstGeom prst="rect">
@@ -3326,7 +3104,7 @@
             </a:br>
             <a:r>
               <a:rPr lang="en-US" sz="1000" i="1" dirty="0">
-                <a:hlinkClick r:id="rId12"/>
+                <a:hlinkClick r:id="rId10"/>
               </a:rPr>
               <a:t>https://cass.community</a:t>
             </a:r>
@@ -3336,10 +3114,10 @@
       </p:sp>
       <p:pic>
         <p:nvPicPr>
-          <p:cNvPr id="33" name="Picture 32" descr="A picture containing arrow&#10;&#10;AI-generated content may be incorrect.">
+          <p:cNvPr id="21" name="Picture 20" descr="A picture containing arrow&#10;&#10;AI-generated content may be incorrect.">
             <a:extLst>
               <a:ext uri="{FF2B5EF4-FFF2-40B4-BE49-F238E27FC236}">
-                <a16:creationId xmlns:a16="http://schemas.microsoft.com/office/drawing/2014/main" id="{B7F73F98-CA13-FB35-8581-26AFB4E15F1A}"/>
+                <a16:creationId xmlns:a16="http://schemas.microsoft.com/office/drawing/2014/main" id="{28040F87-B305-0E89-E938-0FF0D86D4128}"/>
               </a:ext>
             </a:extLst>
           </p:cNvPr>
@@ -3349,7 +3127,7 @@
           <p:nvPr userDrawn="1"/>
         </p:nvPicPr>
         <p:blipFill>
-          <a:blip r:embed="rId13" cstate="print">
+          <a:blip r:embed="rId11" cstate="print">
             <a:extLst>
               <a:ext uri="{28A0092B-C50C-407E-A947-70E740481C1C}">
                 <a14:useLocalDpi xmlns:a14="http://schemas.microsoft.com/office/drawing/2010/main" val="0"/>
@@ -3362,7 +3140,7 @@
         </p:blipFill>
         <p:spPr>
           <a:xfrm>
-            <a:off x="849769" y="2974535"/>
+            <a:off x="732002" y="2974535"/>
             <a:ext cx="1238034" cy="1128739"/>
           </a:xfrm>
           <a:prstGeom prst="rect">
@@ -5825,7 +5603,7 @@
         <p:spPr>
           <a:xfrm>
             <a:off x="3176924" y="2085870"/>
-            <a:ext cx="2034531" cy="424732"/>
+            <a:ext cx="2752677" cy="424732"/>
           </a:xfrm>
         </p:spPr>
         <p:txBody>
@@ -5834,7 +5612,7 @@
           <a:p>
             <a:r>
               <a:rPr lang="en-US" dirty="0"/>
-              <a:t>Anshu Dubey</a:t>
+              <a:t>David E. Bernholdt</a:t>
             </a:r>
           </a:p>
         </p:txBody>
@@ -5857,7 +5635,7 @@
         </p:nvSpPr>
         <p:spPr>
           <a:xfrm>
-            <a:off x="5176191" y="2140952"/>
+            <a:off x="5858116" y="2140952"/>
             <a:ext cx="1690167" cy="376085"/>
           </a:xfrm>
         </p:spPr>
@@ -5867,7 +5645,7 @@
           <a:p>
             <a:r>
               <a:rPr lang="en-US" dirty="0"/>
-              <a:t>(she/her)</a:t>
+              <a:t>(he/him)</a:t>
             </a:r>
           </a:p>
         </p:txBody>
@@ -5895,7 +5673,7 @@
           <a:p>
             <a:r>
               <a:rPr lang="en-US" dirty="0"/>
-              <a:t>Argonne National Laboratory</a:t>
+              <a:t>Oak Ridge National Laboratory</a:t>
             </a:r>
           </a:p>
         </p:txBody>
@@ -5932,29 +5710,13 @@
               </a:spcBef>
             </a:pPr>
             <a:r>
-              <a:rPr lang="en-US" sz="2000" b="0" i="0" dirty="0">
-                <a:solidFill>
-                  <a:srgbClr val="111111"/>
-                </a:solidFill>
-                <a:effectLst/>
-                <a:latin typeface="+mn-lt"/>
-              </a:rPr>
-              <a:t>Better Software for Reproducible Science tutorial @ SCA/HPC-Asia 2026 Conferenc</a:t>
-            </a:r>
-            <a:r>
-              <a:rPr lang="en-US" dirty="0">
-                <a:solidFill>
-                  <a:srgbClr val="111111"/>
-                </a:solidFill>
-              </a:rPr>
-              <a:t>e, Osaka, Japan</a:t>
-            </a:r>
-            <a:endParaRPr lang="en-US" sz="2000" b="0" i="0" dirty="0">
+              <a:rPr lang="en-US" dirty="0"/>
+              <a:t>Software Sustainability track @ Argonne Training Program on Extreme-Scale Computing summer school</a:t>
+            </a:r>
+            <a:endParaRPr lang="en-US" dirty="0">
               <a:solidFill>
                 <a:srgbClr val="111111"/>
               </a:solidFill>
-              <a:effectLst/>
-              <a:latin typeface="+mn-lt"/>
             </a:endParaRPr>
           </a:p>
         </p:txBody>
@@ -6011,7 +5773,7 @@
         <p:spPr>
           <a:xfrm>
             <a:off x="3176924" y="4242168"/>
-            <a:ext cx="8292316" cy="369332"/>
+            <a:ext cx="8292316" cy="646331"/>
           </a:xfrm>
         </p:spPr>
         <p:txBody>
@@ -6020,7 +5782,7 @@
           <a:p>
             <a:r>
               <a:rPr lang="en-US" sz="2000" dirty="0"/>
-              <a:t>Contributors: Anshu Dubey (ANL), Jared O’Neal</a:t>
+              <a:t>Contributors: David E. Bernholdt (ORNL), Anshu Dubey (ANL), Jared O’Neal</a:t>
             </a:r>
           </a:p>
         </p:txBody>
@@ -6039,7 +5801,7 @@
 </file>
 
 <file path=ppt/slides/slide10.xml><?xml version="1.0" encoding="utf-8"?>
-<p:sld xmlns:a="http://schemas.openxmlformats.org/drawingml/2006/main" xmlns:r="http://schemas.openxmlformats.org/officeDocument/2006/relationships" xmlns:p="http://schemas.openxmlformats.org/presentationml/2006/main">
+<p:sld xmlns:a="http://schemas.openxmlformats.org/drawingml/2006/main" xmlns:r="http://schemas.openxmlformats.org/officeDocument/2006/relationships" xmlns:p="http://schemas.openxmlformats.org/presentationml/2006/main" show="0">
   <p:cSld>
     <p:spTree>
       <p:nvGrpSpPr>
@@ -6663,13 +6425,13 @@
   <p:clrMapOvr>
     <a:masterClrMapping/>
   </p:clrMapOvr>
-  <mc:AlternateContent xmlns:mc="http://schemas.openxmlformats.org/markup-compatibility/2006" xmlns:p14="http://schemas.microsoft.com/office/powerpoint/2010/main">
-    <mc:Choice Requires="p14">
+  <mc:AlternateContent xmlns:mc="http://schemas.openxmlformats.org/markup-compatibility/2006">
+    <mc:Choice xmlns:p14="http://schemas.microsoft.com/office/powerpoint/2010/main" Requires="p14">
       <p:transition p14:dur="250">
         <p:fade/>
       </p:transition>
     </mc:Choice>
-    <mc:Fallback xmlns="">
+    <mc:Fallback>
       <p:transition>
         <p:fade/>
       </p:transition>
@@ -6679,7 +6441,7 @@
 </file>
 
 <file path=ppt/slides/slide11.xml><?xml version="1.0" encoding="utf-8"?>
-<p:sld xmlns:a="http://schemas.openxmlformats.org/drawingml/2006/main" xmlns:r="http://schemas.openxmlformats.org/officeDocument/2006/relationships" xmlns:p="http://schemas.openxmlformats.org/presentationml/2006/main">
+<p:sld xmlns:a="http://schemas.openxmlformats.org/drawingml/2006/main" xmlns:r="http://schemas.openxmlformats.org/officeDocument/2006/relationships" xmlns:p="http://schemas.openxmlformats.org/presentationml/2006/main" show="0">
   <p:cSld>
     <p:spTree>
       <p:nvGrpSpPr>
@@ -7544,13 +7306,13 @@
   <p:clrMapOvr>
     <a:masterClrMapping/>
   </p:clrMapOvr>
-  <mc:AlternateContent xmlns:mc="http://schemas.openxmlformats.org/markup-compatibility/2006" xmlns:p14="http://schemas.microsoft.com/office/powerpoint/2010/main">
-    <mc:Choice Requires="p14">
+  <mc:AlternateContent xmlns:mc="http://schemas.openxmlformats.org/markup-compatibility/2006">
+    <mc:Choice xmlns:p14="http://schemas.microsoft.com/office/powerpoint/2010/main" Requires="p14">
       <p:transition p14:dur="250">
         <p:fade/>
       </p:transition>
     </mc:Choice>
-    <mc:Fallback xmlns="">
+    <mc:Fallback>
       <p:transition>
         <p:fade/>
       </p:transition>
@@ -7560,7 +7322,7 @@
 </file>
 
 <file path=ppt/slides/slide12.xml><?xml version="1.0" encoding="utf-8"?>
-<p:sld xmlns:a="http://schemas.openxmlformats.org/drawingml/2006/main" xmlns:r="http://schemas.openxmlformats.org/officeDocument/2006/relationships" xmlns:p="http://schemas.openxmlformats.org/presentationml/2006/main">
+<p:sld xmlns:a="http://schemas.openxmlformats.org/drawingml/2006/main" xmlns:r="http://schemas.openxmlformats.org/officeDocument/2006/relationships" xmlns:p="http://schemas.openxmlformats.org/presentationml/2006/main" show="0">
   <p:cSld>
     <p:spTree>
       <p:nvGrpSpPr>
@@ -8499,13 +8261,13 @@
   <p:clrMapOvr>
     <a:masterClrMapping/>
   </p:clrMapOvr>
-  <mc:AlternateContent xmlns:mc="http://schemas.openxmlformats.org/markup-compatibility/2006" xmlns:p14="http://schemas.microsoft.com/office/powerpoint/2010/main">
-    <mc:Choice Requires="p14">
+  <mc:AlternateContent xmlns:mc="http://schemas.openxmlformats.org/markup-compatibility/2006">
+    <mc:Choice xmlns:p14="http://schemas.microsoft.com/office/powerpoint/2010/main" Requires="p14">
       <p:transition p14:dur="250">
         <p:fade/>
       </p:transition>
     </mc:Choice>
-    <mc:Fallback xmlns="">
+    <mc:Fallback>
       <p:transition>
         <p:fade/>
       </p:transition>
@@ -16806,7 +16568,7 @@
         </p:nvSpPr>
         <p:spPr>
           <a:xfrm>
-            <a:off x="363096" y="112911"/>
+            <a:off x="363096" y="411282"/>
             <a:ext cx="11372473" cy="914400"/>
           </a:xfrm>
         </p:spPr>
@@ -16839,7 +16601,7 @@
         </p:nvSpPr>
         <p:spPr>
           <a:xfrm>
-            <a:off x="409507" y="570111"/>
+            <a:off x="409507" y="868482"/>
             <a:ext cx="11369809" cy="4047778"/>
           </a:xfrm>
         </p:spPr>
@@ -16894,13 +16656,13 @@
             </a:r>
             <a:r>
               <a:rPr lang="en-US" sz="1600" dirty="0"/>
-              <a:t>Anshu Dubey, David E. Bernholdt, and Todd Gamblin, Software Sustainability track, in Argonne Training Program on Extreme-Scale Computing, St. Charles, Illinois, 2025. DOI: </a:t>
+              <a:t>David E. Bernholdt, Software Sustainability track, in Argonne Training Program on Extreme-Scale Computing, St. Charles, Illinois, 2026. DOI: </a:t>
             </a:r>
             <a:r>
               <a:rPr lang="en-US" sz="1600" dirty="0">
                 <a:hlinkClick r:id="rId4"/>
               </a:rPr>
-              <a:t>10.6084/m9.figshare.29816981</a:t>
+              <a:t>10.6084/m9.figshare.33139910</a:t>
             </a:r>
             <a:r>
               <a:rPr lang="en-US" sz="1600" dirty="0"/>
@@ -16967,11 +16729,15 @@
             </a:pPr>
             <a:r>
               <a:rPr lang="en-US" sz="1400" dirty="0"/>
-              <a:t>This work was supported by the U.S. Department of Energy Office of Science, Office of Advanced Scientific Computing Research (ASCR), and by the Exascale Computing Project (17-SC-20-SC), a collaborative effort of the U.S. Department of Energy Office of Science and the National Nuclear Security Administration</a:t>
-            </a:r>
-            <a:r>
-              <a:rPr lang="en-US" sz="1400" i="1" dirty="0"/>
-              <a:t>.</a:t>
+              <a:t>This work was supported by the U.S. Department of Energy, Office of Science, Office of Advanced Scientific Computing Research, Next-Generation Scientific Software Technologies (NGSST) and Scientific Discovery through Advanced Computing (</a:t>
+            </a:r>
+            <a:r>
+              <a:rPr lang="en-US" sz="1400" dirty="0" err="1"/>
+              <a:t>SciDAC</a:t>
+            </a:r>
+            <a:r>
+              <a:rPr lang="en-US" sz="1400" dirty="0"/>
+              <a:t>) programs.</a:t>
             </a:r>
           </a:p>
           <a:p>
@@ -16981,11 +16747,12 @@
               </a:spcBef>
             </a:pPr>
             <a:r>
-              <a:rPr lang="en-US" sz="1400" b="0" i="0" dirty="0">
-                <a:effectLst/>
-                <a:latin typeface="+mn-lt"/>
-              </a:rPr>
-              <a:t>This work was supported by the U.S. Department of Energy, Office of Science, Office of Advanced Scientific Computing Research, Next-Generation Scientific Software Technologies (NGSST) program.</a:t>
+              <a:rPr lang="en-US" sz="1400" dirty="0"/>
+              <a:t>This work was supported by the U.S. Department of Energy Office of Science, Office of Advanced Scientific Computing Research (ASCR), and by the Exascale Computing Project (17-SC-20-SC), a collaborative effort of the U.S. Department of Energy Office of Science and the National Nuclear Security Administration</a:t>
+            </a:r>
+            <a:r>
+              <a:rPr lang="en-US" sz="1400" i="1" dirty="0"/>
+              <a:t>.</a:t>
             </a:r>
           </a:p>
           <a:p>
@@ -17095,7 +16862,7 @@
     </p:spTree>
     <p:extLst>
       <p:ext uri="{BB962C8B-B14F-4D97-AF65-F5344CB8AC3E}">
-        <p14:creationId xmlns:p14="http://schemas.microsoft.com/office/powerpoint/2010/main" val="978726433"/>
+        <p14:creationId xmlns:p14="http://schemas.microsoft.com/office/powerpoint/2010/main" val="3509392345"/>
       </p:ext>
     </p:extLst>
   </p:cSld>
@@ -29264,7 +29031,7 @@
 </file>
 
 <file path=ppt/slides/slide9.xml><?xml version="1.0" encoding="utf-8"?>
-<p:sld xmlns:a="http://schemas.openxmlformats.org/drawingml/2006/main" xmlns:r="http://schemas.openxmlformats.org/officeDocument/2006/relationships" xmlns:p="http://schemas.openxmlformats.org/presentationml/2006/main">
+<p:sld xmlns:a="http://schemas.openxmlformats.org/drawingml/2006/main" xmlns:r="http://schemas.openxmlformats.org/officeDocument/2006/relationships" xmlns:p="http://schemas.openxmlformats.org/presentationml/2006/main" show="0">
   <p:cSld>
     <p:spTree>
       <p:nvGrpSpPr>
@@ -30525,18 +30292,18 @@
 </file>
 
 <file path=customXml/item1.xml><?xml version="1.0" encoding="utf-8"?>
+<p:properties xmlns:p="http://schemas.microsoft.com/office/2006/metadata/properties" xmlns:xsi="http://www.w3.org/2001/XMLSchema-instance" xmlns:pc="http://schemas.microsoft.com/office/infopath/2007/PartnerControls">
+  <documentManagement/>
+</p:properties>
+</file>
+
+<file path=customXml/item2.xml><?xml version="1.0" encoding="utf-8"?>
 <?mso-contentType ?>
 <FormTemplates xmlns="http://schemas.microsoft.com/sharepoint/v3/contenttype/forms">
   <Display>DocumentLibraryForm</Display>
   <Edit>DocumentLibraryForm</Edit>
   <New>DocumentLibraryForm</New>
 </FormTemplates>
-</file>
-
-<file path=customXml/item2.xml><?xml version="1.0" encoding="utf-8"?>
-<p:properties xmlns:p="http://schemas.microsoft.com/office/2006/metadata/properties" xmlns:xsi="http://www.w3.org/2001/XMLSchema-instance" xmlns:pc="http://schemas.microsoft.com/office/infopath/2007/PartnerControls">
-  <documentManagement/>
-</p:properties>
 </file>
 
 <file path=customXml/item3.xml><?xml version="1.0" encoding="utf-8"?>
@@ -30589,14 +30356,6 @@
 </file>
 
 <file path=customXml/itemProps1.xml><?xml version="1.0" encoding="utf-8"?>
-<ds:datastoreItem xmlns:ds="http://schemas.openxmlformats.org/officeDocument/2006/customXml" ds:itemID="{19E20559-B232-4371-8690-E3D8007EDB82}">
-  <ds:schemaRefs>
-    <ds:schemaRef ds:uri="http://schemas.microsoft.com/sharepoint/v3/contenttype/forms"/>
-  </ds:schemaRefs>
-</ds:datastoreItem>
-</file>
-
-<file path=customXml/itemProps2.xml><?xml version="1.0" encoding="utf-8"?>
 <ds:datastoreItem xmlns:ds="http://schemas.openxmlformats.org/officeDocument/2006/customXml" ds:itemID="{A50EC660-24D0-43A0-AE5E-E274115E726B}">
   <ds:schemaRefs>
     <ds:schemaRef ds:uri="http://purl.org/dc/elements/1.1/"/>
@@ -30607,6 +30366,14 @@
     <ds:schemaRef ds:uri="http://www.w3.org/XML/1998/namespace"/>
     <ds:schemaRef ds:uri="http://purl.org/dc/dcmitype/"/>
     <ds:schemaRef ds:uri="http://schemas.microsoft.com/office/infopath/2007/PartnerControls"/>
+  </ds:schemaRefs>
+</ds:datastoreItem>
+</file>
+
+<file path=customXml/itemProps2.xml><?xml version="1.0" encoding="utf-8"?>
+<ds:datastoreItem xmlns:ds="http://schemas.openxmlformats.org/officeDocument/2006/customXml" ds:itemID="{19E20559-B232-4371-8690-E3D8007EDB82}">
+  <ds:schemaRefs>
+    <ds:schemaRef ds:uri="http://schemas.microsoft.com/sharepoint/v3/contenttype/forms"/>
   </ds:schemaRefs>
 </ds:datastoreItem>
 </file>

</xml_diff>